<commit_message>
Actualizar desglose de contenido: 4 videos, 3 post, 3 plantillas de historias
Co-Authored-By: Claude Fable 5 <noreply@anthropic.com>
Claude-Session: https://claude.ai/code/session_01KpH8oR29wiBhy4iSar9w76
</commit_message>
<xml_diff>
--- a/extravagance/Propuesta_Medusssa_Extravagance.pptx
+++ b/extravagance/Propuesta_Medusssa_Extravagance.pptx
@@ -4690,7 +4690,7 @@
                 <a:ea typeface="Open Sans" pitchFamily="34" charset="-122"/>
                 <a:cs typeface="Open Sans" pitchFamily="34" charset="-120"/>
               </a:rPr>
-              <a:t>3</a:t>
+              <a:t>4</a:t>
             </a:r>
             <a:endParaRPr lang="en-US" sz="1300" dirty="0"/>
           </a:p>
@@ -4705,7 +4705,7 @@
         <p:spPr>
           <a:xfrm>
             <a:off x="1221740" y="3366643"/>
-            <a:ext cx="1016000" cy="187008"/>
+            <a:ext cx="1524000" cy="187008"/>
           </a:xfrm>
           <a:prstGeom prst="rect">
             <a:avLst/>
@@ -4729,7 +4729,7 @@
                 <a:ea typeface="Open Sans" pitchFamily="34" charset="-122"/>
                 <a:cs typeface="Open Sans" pitchFamily="34" charset="-120"/>
               </a:rPr>
-              <a:t>REELS</a:t>
+              <a:t>Videos</a:t>
             </a:r>
             <a:endParaRPr lang="en-US" sz="950" dirty="0"/>
           </a:p>
@@ -4768,7 +4768,7 @@
                 <a:ea typeface="Open Sans" pitchFamily="34" charset="-122"/>
                 <a:cs typeface="Open Sans" pitchFamily="34" charset="-120"/>
               </a:rPr>
-              <a:t>10</a:t>
+              <a:t>3</a:t>
             </a:r>
             <a:endParaRPr lang="en-US" sz="1300" dirty="0"/>
           </a:p>
@@ -4782,8 +4782,8 @@
         </p:nvSpPr>
         <p:spPr>
           <a:xfrm>
-            <a:off x="1304290" y="3804793"/>
-            <a:ext cx="1016000" cy="187008"/>
+            <a:off x="1221740" y="3804793"/>
+            <a:ext cx="2159000" cy="187008"/>
           </a:xfrm>
           <a:prstGeom prst="rect">
             <a:avLst/>
@@ -4807,7 +4807,7 @@
                 <a:ea typeface="Open Sans" pitchFamily="34" charset="-122"/>
                 <a:cs typeface="Open Sans" pitchFamily="34" charset="-120"/>
               </a:rPr>
-              <a:t>Post</a:t>
+              <a:t>Post de imágenes promocionales</a:t>
             </a:r>
             <a:endParaRPr lang="en-US" sz="950" dirty="0"/>
           </a:p>
@@ -4846,7 +4846,7 @@
                 <a:ea typeface="Open Sans" pitchFamily="34" charset="-122"/>
                 <a:cs typeface="Open Sans" pitchFamily="34" charset="-120"/>
               </a:rPr>
-              <a:t>7</a:t>
+              <a:t>3</a:t>
             </a:r>
             <a:endParaRPr lang="en-US" sz="1300" dirty="0"/>
           </a:p>
@@ -4861,7 +4861,7 @@
         <p:spPr>
           <a:xfrm>
             <a:off x="1220470" y="4244213"/>
-            <a:ext cx="1270000" cy="187008"/>
+            <a:ext cx="2159000" cy="187008"/>
           </a:xfrm>
           <a:prstGeom prst="rect">
             <a:avLst/>
@@ -4885,7 +4885,7 @@
                 <a:ea typeface="Open Sans" pitchFamily="34" charset="-122"/>
                 <a:cs typeface="Open Sans" pitchFamily="34" charset="-120"/>
               </a:rPr>
-              <a:t>P l a n t i l l a s</a:t>
+              <a:t>Plantillas de historias</a:t>
             </a:r>
             <a:endParaRPr lang="en-US" sz="950" dirty="0"/>
           </a:p>

</xml_diff>